<commit_message>
UPDATE: revising the reports
</commit_message>
<xml_diff>
--- a/results/reports/presentation.pptx
+++ b/results/reports/presentation.pptx
@@ -114,6 +114,11 @@
       </a:defRPr>
     </a:lvl9pPr>
   </p:defaultTextStyle>
+  <p:extLst>
+    <p:ext uri="{EFAFB233-063F-42B5-8137-9DF3F51BA10A}">
+      <p15:sldGuideLst xmlns:p15="http://schemas.microsoft.com/office/powerpoint/2012/main"/>
+    </p:ext>
+  </p:extLst>
 </p:presentation>
 </file>
 
@@ -6108,7 +6113,7 @@
           <a:p>
             <a:fld id="{9B5D1B5B-6FD7-4572-A129-52C6614904C4}" type="datetimeFigureOut">
               <a:rPr lang="en-US" smtClean="0"/>
-              <a:t>3/26/2026</a:t>
+              <a:t>3/27/2026</a:t>
             </a:fld>
             <a:endParaRPr lang="en-US"/>
           </a:p>
@@ -6383,7 +6388,7 @@
           <a:p>
             <a:fld id="{9B5D1B5B-6FD7-4572-A129-52C6614904C4}" type="datetimeFigureOut">
               <a:rPr lang="en-US" smtClean="0"/>
-              <a:t>3/26/2026</a:t>
+              <a:t>3/27/2026</a:t>
             </a:fld>
             <a:endParaRPr lang="en-US"/>
           </a:p>
@@ -6577,7 +6582,7 @@
           <a:p>
             <a:fld id="{9B5D1B5B-6FD7-4572-A129-52C6614904C4}" type="datetimeFigureOut">
               <a:rPr lang="en-US" smtClean="0"/>
-              <a:t>3/26/2026</a:t>
+              <a:t>3/27/2026</a:t>
             </a:fld>
             <a:endParaRPr lang="en-US"/>
           </a:p>
@@ -6850,7 +6855,7 @@
           <a:p>
             <a:fld id="{9B5D1B5B-6FD7-4572-A129-52C6614904C4}" type="datetimeFigureOut">
               <a:rPr lang="en-US" smtClean="0"/>
-              <a:t>3/26/2026</a:t>
+              <a:t>3/27/2026</a:t>
             </a:fld>
             <a:endParaRPr lang="en-US"/>
           </a:p>
@@ -7191,7 +7196,7 @@
           <a:p>
             <a:fld id="{9B5D1B5B-6FD7-4572-A129-52C6614904C4}" type="datetimeFigureOut">
               <a:rPr lang="en-US" smtClean="0"/>
-              <a:t>3/26/2026</a:t>
+              <a:t>3/27/2026</a:t>
             </a:fld>
             <a:endParaRPr lang="en-US"/>
           </a:p>
@@ -7814,7 +7819,7 @@
           <a:p>
             <a:fld id="{9B5D1B5B-6FD7-4572-A129-52C6614904C4}" type="datetimeFigureOut">
               <a:rPr lang="en-US" smtClean="0"/>
-              <a:t>3/26/2026</a:t>
+              <a:t>3/27/2026</a:t>
             </a:fld>
             <a:endParaRPr lang="en-US"/>
           </a:p>
@@ -8674,7 +8679,7 @@
           <a:p>
             <a:fld id="{9B5D1B5B-6FD7-4572-A129-52C6614904C4}" type="datetimeFigureOut">
               <a:rPr lang="en-US" smtClean="0"/>
-              <a:t>3/26/2026</a:t>
+              <a:t>3/27/2026</a:t>
             </a:fld>
             <a:endParaRPr lang="en-US"/>
           </a:p>
@@ -8844,7 +8849,7 @@
           <a:p>
             <a:fld id="{9B5D1B5B-6FD7-4572-A129-52C6614904C4}" type="datetimeFigureOut">
               <a:rPr lang="en-US" smtClean="0"/>
-              <a:t>3/26/2026</a:t>
+              <a:t>3/27/2026</a:t>
             </a:fld>
             <a:endParaRPr lang="en-US"/>
           </a:p>
@@ -9024,7 +9029,7 @@
           <a:p>
             <a:fld id="{9B5D1B5B-6FD7-4572-A129-52C6614904C4}" type="datetimeFigureOut">
               <a:rPr lang="en-US" smtClean="0"/>
-              <a:t>3/26/2026</a:t>
+              <a:t>3/27/2026</a:t>
             </a:fld>
             <a:endParaRPr lang="en-US"/>
           </a:p>
@@ -9194,7 +9199,7 @@
           <a:p>
             <a:fld id="{9B5D1B5B-6FD7-4572-A129-52C6614904C4}" type="datetimeFigureOut">
               <a:rPr lang="en-US" smtClean="0"/>
-              <a:t>3/26/2026</a:t>
+              <a:t>3/27/2026</a:t>
             </a:fld>
             <a:endParaRPr lang="en-US"/>
           </a:p>
@@ -9441,7 +9446,7 @@
           <a:p>
             <a:fld id="{9B5D1B5B-6FD7-4572-A129-52C6614904C4}" type="datetimeFigureOut">
               <a:rPr lang="en-US" smtClean="0"/>
-              <a:t>3/26/2026</a:t>
+              <a:t>3/27/2026</a:t>
             </a:fld>
             <a:endParaRPr lang="en-US"/>
           </a:p>
@@ -9733,7 +9738,7 @@
           <a:p>
             <a:fld id="{9B5D1B5B-6FD7-4572-A129-52C6614904C4}" type="datetimeFigureOut">
               <a:rPr lang="en-US" smtClean="0"/>
-              <a:t>3/26/2026</a:t>
+              <a:t>3/27/2026</a:t>
             </a:fld>
             <a:endParaRPr lang="en-US"/>
           </a:p>
@@ -10177,7 +10182,7 @@
           <a:p>
             <a:fld id="{9B5D1B5B-6FD7-4572-A129-52C6614904C4}" type="datetimeFigureOut">
               <a:rPr lang="en-US" smtClean="0"/>
-              <a:t>3/26/2026</a:t>
+              <a:t>3/27/2026</a:t>
             </a:fld>
             <a:endParaRPr lang="en-US"/>
           </a:p>
@@ -10295,7 +10300,7 @@
           <a:p>
             <a:fld id="{9B5D1B5B-6FD7-4572-A129-52C6614904C4}" type="datetimeFigureOut">
               <a:rPr lang="en-US" smtClean="0"/>
-              <a:t>3/26/2026</a:t>
+              <a:t>3/27/2026</a:t>
             </a:fld>
             <a:endParaRPr lang="en-US"/>
           </a:p>
@@ -10390,7 +10395,7 @@
           <a:p>
             <a:fld id="{9B5D1B5B-6FD7-4572-A129-52C6614904C4}" type="datetimeFigureOut">
               <a:rPr lang="en-US" smtClean="0"/>
-              <a:t>3/26/2026</a:t>
+              <a:t>3/27/2026</a:t>
             </a:fld>
             <a:endParaRPr lang="en-US"/>
           </a:p>
@@ -10669,7 +10674,7 @@
           <a:p>
             <a:fld id="{9B5D1B5B-6FD7-4572-A129-52C6614904C4}" type="datetimeFigureOut">
               <a:rPr lang="en-US" smtClean="0"/>
-              <a:t>3/26/2026</a:t>
+              <a:t>3/27/2026</a:t>
             </a:fld>
             <a:endParaRPr lang="en-US"/>
           </a:p>
@@ -10944,7 +10949,7 @@
           <a:p>
             <a:fld id="{9B5D1B5B-6FD7-4572-A129-52C6614904C4}" type="datetimeFigureOut">
               <a:rPr lang="en-US" smtClean="0"/>
-              <a:t>3/26/2026</a:t>
+              <a:t>3/27/2026</a:t>
             </a:fld>
             <a:endParaRPr lang="en-US"/>
           </a:p>
@@ -11147,6 +11152,13 @@
             <a:schemeClr val="lt1"/>
           </a:fontRef>
         </p:style>
+        <p:txBody>
+          <a:bodyPr/>
+          <a:lstStyle/>
+          <a:p>
+            <a:endParaRPr lang="en-US"/>
+          </a:p>
+        </p:txBody>
       </p:sp>
       <p:pic>
         <p:nvPicPr>
@@ -11241,6 +11253,13 @@
             <a:schemeClr val="lt1"/>
           </a:fontRef>
         </p:style>
+        <p:txBody>
+          <a:bodyPr/>
+          <a:lstStyle/>
+          <a:p>
+            <a:endParaRPr lang="en-US"/>
+          </a:p>
+        </p:txBody>
       </p:sp>
       <p:sp>
         <p:nvSpPr>
@@ -11373,7 +11392,7 @@
           <a:p>
             <a:fld id="{9B5D1B5B-6FD7-4572-A129-52C6614904C4}" type="datetimeFigureOut">
               <a:rPr lang="en-US" smtClean="0"/>
-              <a:t>3/26/2026</a:t>
+              <a:t>3/27/2026</a:t>
             </a:fld>
             <a:endParaRPr lang="en-US"/>
           </a:p>

</xml_diff>

<commit_message>
UPDATE: revising the presentation
</commit_message>
<xml_diff>
--- a/results/reports/presentation.pptx
+++ b/results/reports/presentation.pptx
@@ -12236,16 +12236,14 @@
           <a:p>
             <a:r>
               <a:rPr lang="en-US" dirty="0"/>
-              <a:t>Adversarial framing can improve reasoning because it introduces a conflict that triggers more cautious and deliberate reasoning.</a:t>
+              <a:t>Adversarial framing does not necessarily increase errors and can sometimes improve reasoning by introducing a conflict that encourages more cautious and deliberate responses.</a:t>
             </a:r>
           </a:p>
           <a:p>
             <a:r>
-              <a:rPr lang="en-US" dirty="0"/>
-              <a:t>Self-verification can be helpful but not always stable specially on strong reasoning models like Claude, smaller reasoning models benefit from it more.</a:t>
+              <a:rPr lang="en-US"/>
+              <a:t>Self-verification can be helpful but is not always stable, especially for strong models like Claude, while smaller models tend to benefit more from it.</a:t>
             </a:r>
-          </a:p>
-          <a:p>
             <a:endParaRPr lang="en-US" dirty="0"/>
           </a:p>
           <a:p>
@@ -13368,20 +13366,8 @@
           <a:p>
             <a:r>
               <a:rPr lang="en-US" dirty="0"/>
-              <a:t>LLMs are used in real-world decision making</a:t>
+              <a:t>Large language models (LLMs) are often deployed in environments where input information may be incomplete, misleading, or factually incorrect.</a:t>
             </a:r>
-          </a:p>
-          <a:p>
-            <a:r>
-              <a:rPr lang="en-US" dirty="0"/>
-              <a:t>Inputs are often incomplete or misleading </a:t>
-            </a:r>
-          </a:p>
-          <a:p>
-            <a:pPr marL="0" indent="0">
-              <a:buNone/>
-            </a:pPr>
-            <a:endParaRPr lang="en-US" dirty="0"/>
           </a:p>
           <a:p>
             <a:pPr marL="0" indent="0">

</xml_diff>